<commit_message>
Locate unregistered outputs and bind native evidence to its corpus - carry the output name and sha-256 on registration failures through a shared recovery exception, filesystem, sharepoint and tools - fail the native record unless results match the exact manifest, case ids, output hashes, every check and the controls - keep corpus json and markdown as lf text so the manifest hash is stable and git diff --check passes - rerun office on the regenerated corpus, 70 of 70 cases, and prove the fixes with 12 removal probes
</commit_message>
<xml_diff>
--- a/tests/OfficeAgent.Tests/Corpus/v1.0.0/native/controls/control-corrupt.pptx
+++ b/tests/OfficeAgent.Tests/Corpus/v1.0.0/native/controls/control-corrupt.pptx
@@ -2,11 +2,11 @@
 <file path=ppt/presentation.xml><?xml version="1.0" encoding="utf-8"?>
 <p:presentation xmlns:p="http://schemas.openxmlformats.org/presentationml/2006/main">
   <p:sldMasterIdLst>
-    <p:sldMasterId xmlns:r="http://schemas.openxmlformats.org/officeDocument/2006/relationships" id="2147483648" r:id="R51c46921e4114669"/>
+    <p:sldMasterId xmlns:r="http://schemas.openxmlformats.org/officeDocument/2006/relationships" id="2147483648" r:id="R7e6bd8948b0341c9"/>
   </p:sldMasterIdLst>
   <p:sldIdLst>
-    <p:sldId xmlns:r="http://schemas.openxmlformats.org/officeDocument/2006/relationships" id="256" r:id="Reb0fcdcd3d1447e5"/>
-    <p:sldId xmlns:r="http://schemas.openxmlformats.org/officeDocument/2006/relationships" id="257" r:id="Redae4695b3fc431c"/>
+    <p:sldId xmlns:r="http://schemas.openxmlformats.org/officeDocument/2006/relationships" id="256" r:id="R83263510b652462a"/>
+    <p:sldId xmlns:r="http://schemas.openxmlformats.org/officeDocument/2006/relationships" id="257" r:id="Rfda3c9668d414d58"/>
   </p:sldIdLst>
   <p:sldSz cx="12192000" cy="6858000"/>
   <p:notesSz cx="6858000" cy="9144000"/>
@@ -80,7 +80,7 @@
   </p:cSld>
   <p:clrMap bg1="lt1" tx1="dk1" bg2="lt2" tx2="dk2" accent1="accent1" accent2="accent2" accent3="accent3" accent4="accent4" accent5="accent5" accent6="accent6" hlink="hlink" folHlink="folHlink"/>
   <p:sldLayoutIdLst>
-    <p:sldLayoutId xmlns:r="http://schemas.openxmlformats.org/officeDocument/2006/relationships" id="2147483649" r:id="R9344acd31c064276"/>
+    <p:sldLayoutId xmlns:r="http://schemas.openxmlformats.org/officeDocument/2006/relationships" id="2147483649" r:id="Rf0280b6dd6b345e6"/>
   </p:sldLayoutIdLst>
 </p:sldMaster>
 </file>

</xml_diff>

<commit_message>
Add formula calculation, Word conformance verbs and core properties for 1.2.0
- add optional OfficeAgent.Excel.Calculation with an allowlisted ClosedXML engine, per-connection settings and formula-error rejection
- add the link and mergeTableCells verbs, numberingId on format, list nodes, compatibility mode and FindHit.ParaId
- store post-2007 Excel functions with their _xlfn. prefix so setCell formulas no longer show #NAME? in Excel
- republish the native Office record with opened controls and new cases, and ship the tenth package in release checks
</commit_message>
<xml_diff>
--- a/tests/OfficeAgent.Tests/Corpus/v1.0.0/native/controls/control-corrupt.pptx
+++ b/tests/OfficeAgent.Tests/Corpus/v1.0.0/native/controls/control-corrupt.pptx
@@ -2,11 +2,11 @@
 <file path=ppt/presentation.xml><?xml version="1.0" encoding="utf-8"?>
 <p:presentation xmlns:p="http://schemas.openxmlformats.org/presentationml/2006/main">
   <p:sldMasterIdLst>
-    <p:sldMasterId xmlns:r="http://schemas.openxmlformats.org/officeDocument/2006/relationships" id="2147483648" r:id="R7e6bd8948b0341c9"/>
+    <p:sldMasterId xmlns:r="http://schemas.openxmlformats.org/officeDocument/2006/relationships" id="2147483648" r:id="R91aa07cfc5d44d3d"/>
   </p:sldMasterIdLst>
   <p:sldIdLst>
-    <p:sldId xmlns:r="http://schemas.openxmlformats.org/officeDocument/2006/relationships" id="256" r:id="R83263510b652462a"/>
-    <p:sldId xmlns:r="http://schemas.openxmlformats.org/officeDocument/2006/relationships" id="257" r:id="Rfda3c9668d414d58"/>
+    <p:sldId xmlns:r="http://schemas.openxmlformats.org/officeDocument/2006/relationships" id="256" r:id="R96c39bc627544b0a"/>
+    <p:sldId xmlns:r="http://schemas.openxmlformats.org/officeDocument/2006/relationships" id="257" r:id="R04df40e5d43b47b3"/>
   </p:sldIdLst>
   <p:sldSz cx="12192000" cy="6858000"/>
   <p:notesSz cx="6858000" cy="9144000"/>
@@ -80,7 +80,7 @@
   </p:cSld>
   <p:clrMap bg1="lt1" tx1="dk1" bg2="lt2" tx2="dk2" accent1="accent1" accent2="accent2" accent3="accent3" accent4="accent4" accent5="accent5" accent6="accent6" hlink="hlink" folHlink="folHlink"/>
   <p:sldLayoutIdLst>
-    <p:sldLayoutId xmlns:r="http://schemas.openxmlformats.org/officeDocument/2006/relationships" id="2147483649" r:id="Rf0280b6dd6b345e6"/>
+    <p:sldLayoutId xmlns:r="http://schemas.openxmlformats.org/officeDocument/2006/relationships" id="2147483649" r:id="R2c15169529f34eb6"/>
   </p:sldLayoutIdLst>
 </p:sldMaster>
 </file>

</xml_diff>

<commit_message>
Add report refresh, formatting-safe translation and multi-document edits
- refresh word reports and powerpoint decks from an excel workbook through xl: bindings with refresh_document
- add fillTable, setChartData and bindData verbs plus formatted cell values and defined names in excel inspection
- keep inline formatting when rewriting a paragraph through markedText and withMarked
- apply one plan to many documents with edit_documents and match every occurrence with "match": "all"
</commit_message>
<xml_diff>
--- a/tests/OfficeAgent.Tests/Corpus/v1.0.0/native/controls/control-corrupt.pptx
+++ b/tests/OfficeAgent.Tests/Corpus/v1.0.0/native/controls/control-corrupt.pptx
@@ -2,11 +2,11 @@
 <file path=ppt/presentation.xml><?xml version="1.0" encoding="utf-8"?>
 <p:presentation xmlns:p="http://schemas.openxmlformats.org/presentationml/2006/main">
   <p:sldMasterIdLst>
-    <p:sldMasterId xmlns:r="http://schemas.openxmlformats.org/officeDocument/2006/relationships" id="2147483648" r:id="R91aa07cfc5d44d3d"/>
+    <p:sldMasterId xmlns:r="http://schemas.openxmlformats.org/officeDocument/2006/relationships" id="2147483648" r:id="Rb7c7d0336ad54e30"/>
   </p:sldMasterIdLst>
   <p:sldIdLst>
-    <p:sldId xmlns:r="http://schemas.openxmlformats.org/officeDocument/2006/relationships" id="256" r:id="R96c39bc627544b0a"/>
-    <p:sldId xmlns:r="http://schemas.openxmlformats.org/officeDocument/2006/relationships" id="257" r:id="R04df40e5d43b47b3"/>
+    <p:sldId xmlns:r="http://schemas.openxmlformats.org/officeDocument/2006/relationships" id="256" r:id="Ra5a86f4339984b0c"/>
+    <p:sldId xmlns:r="http://schemas.openxmlformats.org/officeDocument/2006/relationships" id="257" r:id="R2f47c0ba48464518"/>
   </p:sldIdLst>
   <p:sldSz cx="12192000" cy="6858000"/>
   <p:notesSz cx="6858000" cy="9144000"/>
@@ -80,7 +80,7 @@
   </p:cSld>
   <p:clrMap bg1="lt1" tx1="dk1" bg2="lt2" tx2="dk2" accent1="accent1" accent2="accent2" accent3="accent3" accent4="accent4" accent5="accent5" accent6="accent6" hlink="hlink" folHlink="folHlink"/>
   <p:sldLayoutIdLst>
-    <p:sldLayoutId xmlns:r="http://schemas.openxmlformats.org/officeDocument/2006/relationships" id="2147483649" r:id="R2c15169529f34eb6"/>
+    <p:sldLayoutId xmlns:r="http://schemas.openxmlformats.org/officeDocument/2006/relationships" id="2147483649" r:id="Ra3c79aa11b684dfd"/>
   </p:sldLayoutIdLst>
 </p:sldMaster>
 </file>

</xml_diff>

<commit_message>
Fix the review findings in refresh, table fills and marked rewrites
- refuse a marked rewrite of a paragraph holding tabs, breaks, fields, note references or pictures
- keep comment and bookmark anchors in filled word cells and strip them from copied rows
- format accounting and currency built-ins, drop copied slide row ids, and guard combination charts
- read each workbook sheet once per refresh and keep bound officeagent charts updatable
</commit_message>
<xml_diff>
--- a/tests/OfficeAgent.Tests/Corpus/v1.0.0/native/controls/control-corrupt.pptx
+++ b/tests/OfficeAgent.Tests/Corpus/v1.0.0/native/controls/control-corrupt.pptx
@@ -2,11 +2,11 @@
 <file path=ppt/presentation.xml><?xml version="1.0" encoding="utf-8"?>
 <p:presentation xmlns:p="http://schemas.openxmlformats.org/presentationml/2006/main">
   <p:sldMasterIdLst>
-    <p:sldMasterId xmlns:r="http://schemas.openxmlformats.org/officeDocument/2006/relationships" id="2147483648" r:id="Rb7c7d0336ad54e30"/>
+    <p:sldMasterId xmlns:r="http://schemas.openxmlformats.org/officeDocument/2006/relationships" id="2147483648" r:id="Rc37f25a4ba7546e6"/>
   </p:sldMasterIdLst>
   <p:sldIdLst>
-    <p:sldId xmlns:r="http://schemas.openxmlformats.org/officeDocument/2006/relationships" id="256" r:id="Ra5a86f4339984b0c"/>
-    <p:sldId xmlns:r="http://schemas.openxmlformats.org/officeDocument/2006/relationships" id="257" r:id="R2f47c0ba48464518"/>
+    <p:sldId xmlns:r="http://schemas.openxmlformats.org/officeDocument/2006/relationships" id="256" r:id="R9b047bb1a64f4a20"/>
+    <p:sldId xmlns:r="http://schemas.openxmlformats.org/officeDocument/2006/relationships" id="257" r:id="Rf32dff5e19064563"/>
   </p:sldIdLst>
   <p:sldSz cx="12192000" cy="6858000"/>
   <p:notesSz cx="6858000" cy="9144000"/>
@@ -80,7 +80,7 @@
   </p:cSld>
   <p:clrMap bg1="lt1" tx1="dk1" bg2="lt2" tx2="dk2" accent1="accent1" accent2="accent2" accent3="accent3" accent4="accent4" accent5="accent5" accent6="accent6" hlink="hlink" folHlink="folHlink"/>
   <p:sldLayoutIdLst>
-    <p:sldLayoutId xmlns:r="http://schemas.openxmlformats.org/officeDocument/2006/relationships" id="2147483649" r:id="Ra3c79aa11b684dfd"/>
+    <p:sldLayoutId xmlns:r="http://schemas.openxmlformats.org/officeDocument/2006/relationships" id="2147483649" r:id="Rbfb46328fe7646a9"/>
   </p:sldLayoutIdLst>
 </p:sldMaster>
 </file>

</xml_diff>

<commit_message>
Put new slides on a template's own layouts by name
- resolve insertSlide layouts against the names powerpoint shows, qualified by master when they repeat
- give a slide on a named layout every placeholder the layout defines, under its own shape names
- list each deck's layouts and placeholders in inspect_document and refuse text a layout has no place for
- republish the native record at 84 of 84 cases with a named-layout slide case
</commit_message>
<xml_diff>
--- a/tests/OfficeAgent.Tests/Corpus/v1.0.0/native/controls/control-corrupt.pptx
+++ b/tests/OfficeAgent.Tests/Corpus/v1.0.0/native/controls/control-corrupt.pptx
@@ -2,11 +2,11 @@
 <file path=ppt/presentation.xml><?xml version="1.0" encoding="utf-8"?>
 <p:presentation xmlns:p="http://schemas.openxmlformats.org/presentationml/2006/main">
   <p:sldMasterIdLst>
-    <p:sldMasterId xmlns:r="http://schemas.openxmlformats.org/officeDocument/2006/relationships" id="2147483648" r:id="Rc37f25a4ba7546e6"/>
+    <p:sldMasterId xmlns:r="http://schemas.openxmlformats.org/officeDocument/2006/relationships" id="2147483648" r:id="R5882be782ab54ccb"/>
   </p:sldMasterIdLst>
   <p:sldIdLst>
-    <p:sldId xmlns:r="http://schemas.openxmlformats.org/officeDocument/2006/relationships" id="256" r:id="R9b047bb1a64f4a20"/>
-    <p:sldId xmlns:r="http://schemas.openxmlformats.org/officeDocument/2006/relationships" id="257" r:id="Rf32dff5e19064563"/>
+    <p:sldId xmlns:r="http://schemas.openxmlformats.org/officeDocument/2006/relationships" id="256" r:id="Rb7aa40a22a5a4831"/>
+    <p:sldId xmlns:r="http://schemas.openxmlformats.org/officeDocument/2006/relationships" id="257" r:id="R67b5116a6b664c31"/>
   </p:sldIdLst>
   <p:sldSz cx="12192000" cy="6858000"/>
   <p:notesSz cx="6858000" cy="9144000"/>
@@ -80,7 +80,7 @@
   </p:cSld>
   <p:clrMap bg1="lt1" tx1="dk1" bg2="lt2" tx2="dk2" accent1="accent1" accent2="accent2" accent3="accent3" accent4="accent4" accent5="accent5" accent6="accent6" hlink="hlink" folHlink="folHlink"/>
   <p:sldLayoutIdLst>
-    <p:sldLayoutId xmlns:r="http://schemas.openxmlformats.org/officeDocument/2006/relationships" id="2147483649" r:id="Rbfb46328fe7646a9"/>
+    <p:sldLayoutId xmlns:r="http://schemas.openxmlformats.org/officeDocument/2006/relationships" id="2147483649" r:id="R0f3762f7a16847c6"/>
   </p:sldLayoutIdLst>
 </p:sldMaster>
 </file>

</xml_diff>